<commit_message>
Add production deployment setup for DigitalOcean
Dockerizes backend (FastAPI + Playwright) and frontend (Next.js standalone),
adds a self-hosted Postgres + Caddy (TLS) Compose stack, and a deployment
guide for a single DigitalOcean Droplet. No secrets included — all env
files remain git-ignored, only .example templates are tracked.

Co-Authored-By: Claude <noreply@anthropic.com>
</commit_message>
<xml_diff>
--- a/ParchiVisa_PitchDeck.pptx
+++ b/ParchiVisa_PitchDeck.pptx
@@ -5219,7 +5219,7 @@
                   <a:srgbClr val="FFFFFF"/>
                 </a:solidFill>
               </a:rPr>
-              <a:t>Asad Ahmad</a:t>
+              <a:t>Asad Amad</a:t>
             </a:r>
             <a:endParaRPr lang="en-US" sz="1500" dirty="0"/>
           </a:p>
@@ -5255,7 +5255,7 @@
                   <a:srgbClr val="60A5FA"/>
                 </a:solidFill>
               </a:rPr>
-              <a:t>Co-Founder &amp; Full-Stack Developer</a:t>
+              <a:t>Founder &amp; Full-Stack Developer</a:t>
             </a:r>
             <a:endParaRPr lang="en-US" sz="1000" dirty="0"/>
           </a:p>
@@ -5428,7 +5428,7 @@
           <a:bodyPr/>
           <a:lstStyle/>
           <a:p>
-            <a:endParaRPr lang="en-US"/>
+            <a:endParaRPr lang="en-US" dirty="0"/>
           </a:p>
         </p:txBody>
       </p:sp>
@@ -5525,7 +5525,7 @@
                   <a:srgbClr val="FFFFFF"/>
                 </a:solidFill>
               </a:rPr>
-              <a:t>Co-Founder (Name TBD)</a:t>
+              <a:t>Aqsa Zahid</a:t>
             </a:r>
             <a:endParaRPr lang="en-US" sz="1500" dirty="0"/>
           </a:p>
@@ -5561,7 +5561,7 @@
                   <a:srgbClr val="60A5FA"/>
                 </a:solidFill>
               </a:rPr>
-              <a:t>Business Development &amp; Operations</a:t>
+              <a:t>Co-Founder &amp; Business Development &amp; Operations</a:t>
             </a:r>
             <a:endParaRPr lang="en-US" sz="1000" dirty="0"/>
           </a:p>

</xml_diff>